<commit_message>
Update Zontal-ELN Signals Integration.pptx
</commit_message>
<xml_diff>
--- a/Zontal/Zontal-ELN Signals Integration.pptx
+++ b/Zontal/Zontal-ELN Signals Integration.pptx
@@ -17,6 +17,7 @@
     <p:sldId id="270" r:id="rId11"/>
     <p:sldId id="269" r:id="rId12"/>
     <p:sldId id="271" r:id="rId13"/>
+    <p:sldId id="272" r:id="rId14"/>
   </p:sldIdLst>
   <p:sldSz cx="12192000" cy="6858000"/>
   <p:notesSz cx="6858000" cy="9144000"/>
@@ -115,6 +116,11 @@
       </a:defRPr>
     </a:lvl9pPr>
   </p:defaultTextStyle>
+  <p:extLst>
+    <p:ext uri="{EFAFB233-063F-42B5-8137-9DF3F51BA10A}">
+      <p15:sldGuideLst xmlns:p15="http://schemas.microsoft.com/office/powerpoint/2012/main"/>
+    </p:ext>
+  </p:extLst>
 </p:presentation>
 </file>
 
@@ -3784,7 +3790,7 @@
               <a:t>"</a:t>
             </a:r>
             <a:r>
-              <a:rPr lang="en-US" b="1" dirty="0"/>
+              <a:rPr lang="en-US" b="1" u="sng" dirty="0"/>
               <a:t>quantity datum</a:t>
             </a:r>
             <a:r>
@@ -3806,7 +3812,7 @@
               <a:t>"</a:t>
             </a:r>
             <a:r>
-              <a:rPr lang="en-US" b="1" dirty="0"/>
+              <a:rPr lang="en-US" b="1" u="sng" dirty="0"/>
               <a:t>value datum</a:t>
             </a:r>
             <a:r>
@@ -3820,7 +3826,7 @@
               <a:t>"</a:t>
             </a:r>
             <a:r>
-              <a:rPr lang="en-US" dirty="0" err="1"/>
+              <a:rPr lang="en-US" b="1" u="sng" dirty="0" err="1"/>
               <a:t>datacube</a:t>
             </a:r>
             <a:r>
@@ -3987,21 +3993,22 @@
             <p:ph idx="1"/>
           </p:nvPr>
         </p:nvSpPr>
-        <p:spPr/>
-        <p:txBody>
-          <a:bodyPr/>
+        <p:spPr>
+          <a:xfrm>
+            <a:off x="1200733" y="1690688"/>
+            <a:ext cx="4356370" cy="4351338"/>
+          </a:xfrm>
+        </p:spPr>
+        <p:txBody>
+          <a:bodyPr>
+            <a:normAutofit/>
+          </a:bodyPr>
           <a:lstStyle/>
           <a:p>
             <a:r>
               <a:rPr lang="en-US" dirty="0"/>
               <a:t>For each property with pattern “quantity datum” or “value datum”, add an entry to the field catalog:</a:t>
             </a:r>
-          </a:p>
-          <a:p>
-            <a:pPr marL="0" indent="0">
-              <a:buNone/>
-            </a:pPr>
-            <a:endParaRPr lang="en-US" dirty="0"/>
           </a:p>
         </p:txBody>
       </p:sp>
@@ -4027,7 +4034,7 @@
         </p:blipFill>
         <p:spPr>
           <a:xfrm>
-            <a:off x="4781449" y="2728785"/>
+            <a:off x="1517041" y="3347783"/>
             <a:ext cx="1448002" cy="1819529"/>
           </a:xfrm>
           <a:prstGeom prst="rect">
@@ -4035,6 +4042,250 @@
           </a:prstGeom>
         </p:spPr>
       </p:pic>
+      <p:pic>
+        <p:nvPicPr>
+          <p:cNvPr id="5" name="Picture 4">
+            <a:extLst>
+              <a:ext uri="{FF2B5EF4-FFF2-40B4-BE49-F238E27FC236}">
+                <a16:creationId xmlns:a16="http://schemas.microsoft.com/office/drawing/2014/main" id="{80A4B002-9383-BF48-B629-A06D72D9311F}"/>
+              </a:ext>
+            </a:extLst>
+          </p:cNvPr>
+          <p:cNvPicPr>
+            <a:picLocks noChangeAspect="1"/>
+          </p:cNvPicPr>
+          <p:nvPr/>
+        </p:nvPicPr>
+        <p:blipFill>
+          <a:blip r:embed="rId3"/>
+          <a:stretch>
+            <a:fillRect/>
+          </a:stretch>
+        </p:blipFill>
+        <p:spPr>
+          <a:xfrm>
+            <a:off x="7556934" y="2361807"/>
+            <a:ext cx="1590897" cy="3791479"/>
+          </a:xfrm>
+          <a:prstGeom prst="rect">
+            <a:avLst/>
+          </a:prstGeom>
+        </p:spPr>
+      </p:pic>
+      <p:sp>
+        <p:nvSpPr>
+          <p:cNvPr id="6" name="Content Placeholder 2">
+            <a:extLst>
+              <a:ext uri="{FF2B5EF4-FFF2-40B4-BE49-F238E27FC236}">
+                <a16:creationId xmlns:a16="http://schemas.microsoft.com/office/drawing/2014/main" id="{5819729A-E95F-877A-C1CC-252E7299B952}"/>
+              </a:ext>
+            </a:extLst>
+          </p:cNvPr>
+          <p:cNvSpPr txBox="1">
+            <a:spLocks/>
+          </p:cNvSpPr>
+          <p:nvPr/>
+        </p:nvSpPr>
+        <p:spPr>
+          <a:xfrm>
+            <a:off x="7222185" y="624380"/>
+            <a:ext cx="4356370" cy="4351338"/>
+          </a:xfrm>
+          <a:prstGeom prst="rect">
+            <a:avLst/>
+          </a:prstGeom>
+        </p:spPr>
+        <p:txBody>
+          <a:bodyPr vert="horz" lIns="91440" tIns="45720" rIns="91440" bIns="45720" rtlCol="0">
+            <a:normAutofit/>
+          </a:bodyPr>
+          <a:lstStyle>
+            <a:lvl1pPr marL="228600" indent="-228600" algn="l" defTabSz="914400" rtl="0" eaLnBrk="1" latinLnBrk="0" hangingPunct="1">
+              <a:lnSpc>
+                <a:spcPct val="90000"/>
+              </a:lnSpc>
+              <a:spcBef>
+                <a:spcPts val="1000"/>
+              </a:spcBef>
+              <a:buFont typeface="Arial" panose="020B0604020202020204" pitchFamily="34" charset="0"/>
+              <a:buChar char="•"/>
+              <a:defRPr sz="2800" kern="1200">
+                <a:solidFill>
+                  <a:schemeClr val="tx1"/>
+                </a:solidFill>
+                <a:latin typeface="+mn-lt"/>
+                <a:ea typeface="+mn-ea"/>
+                <a:cs typeface="+mn-cs"/>
+              </a:defRPr>
+            </a:lvl1pPr>
+            <a:lvl2pPr marL="685800" indent="-228600" algn="l" defTabSz="914400" rtl="0" eaLnBrk="1" latinLnBrk="0" hangingPunct="1">
+              <a:lnSpc>
+                <a:spcPct val="90000"/>
+              </a:lnSpc>
+              <a:spcBef>
+                <a:spcPts val="500"/>
+              </a:spcBef>
+              <a:buFont typeface="Arial" panose="020B0604020202020204" pitchFamily="34" charset="0"/>
+              <a:buChar char="•"/>
+              <a:defRPr sz="2400" kern="1200">
+                <a:solidFill>
+                  <a:schemeClr val="tx1"/>
+                </a:solidFill>
+                <a:latin typeface="+mn-lt"/>
+                <a:ea typeface="+mn-ea"/>
+                <a:cs typeface="+mn-cs"/>
+              </a:defRPr>
+            </a:lvl2pPr>
+            <a:lvl3pPr marL="1143000" indent="-228600" algn="l" defTabSz="914400" rtl="0" eaLnBrk="1" latinLnBrk="0" hangingPunct="1">
+              <a:lnSpc>
+                <a:spcPct val="90000"/>
+              </a:lnSpc>
+              <a:spcBef>
+                <a:spcPts val="500"/>
+              </a:spcBef>
+              <a:buFont typeface="Arial" panose="020B0604020202020204" pitchFamily="34" charset="0"/>
+              <a:buChar char="•"/>
+              <a:defRPr sz="2000" kern="1200">
+                <a:solidFill>
+                  <a:schemeClr val="tx1"/>
+                </a:solidFill>
+                <a:latin typeface="+mn-lt"/>
+                <a:ea typeface="+mn-ea"/>
+                <a:cs typeface="+mn-cs"/>
+              </a:defRPr>
+            </a:lvl3pPr>
+            <a:lvl4pPr marL="1600200" indent="-228600" algn="l" defTabSz="914400" rtl="0" eaLnBrk="1" latinLnBrk="0" hangingPunct="1">
+              <a:lnSpc>
+                <a:spcPct val="90000"/>
+              </a:lnSpc>
+              <a:spcBef>
+                <a:spcPts val="500"/>
+              </a:spcBef>
+              <a:buFont typeface="Arial" panose="020B0604020202020204" pitchFamily="34" charset="0"/>
+              <a:buChar char="•"/>
+              <a:defRPr sz="1800" kern="1200">
+                <a:solidFill>
+                  <a:schemeClr val="tx1"/>
+                </a:solidFill>
+                <a:latin typeface="+mn-lt"/>
+                <a:ea typeface="+mn-ea"/>
+                <a:cs typeface="+mn-cs"/>
+              </a:defRPr>
+            </a:lvl4pPr>
+            <a:lvl5pPr marL="2057400" indent="-228600" algn="l" defTabSz="914400" rtl="0" eaLnBrk="1" latinLnBrk="0" hangingPunct="1">
+              <a:lnSpc>
+                <a:spcPct val="90000"/>
+              </a:lnSpc>
+              <a:spcBef>
+                <a:spcPts val="500"/>
+              </a:spcBef>
+              <a:buFont typeface="Arial" panose="020B0604020202020204" pitchFamily="34" charset="0"/>
+              <a:buChar char="•"/>
+              <a:defRPr sz="1800" kern="1200">
+                <a:solidFill>
+                  <a:schemeClr val="tx1"/>
+                </a:solidFill>
+                <a:latin typeface="+mn-lt"/>
+                <a:ea typeface="+mn-ea"/>
+                <a:cs typeface="+mn-cs"/>
+              </a:defRPr>
+            </a:lvl5pPr>
+            <a:lvl6pPr marL="2514600" indent="-228600" algn="l" defTabSz="914400" rtl="0" eaLnBrk="1" latinLnBrk="0" hangingPunct="1">
+              <a:lnSpc>
+                <a:spcPct val="90000"/>
+              </a:lnSpc>
+              <a:spcBef>
+                <a:spcPts val="500"/>
+              </a:spcBef>
+              <a:buFont typeface="Arial" panose="020B0604020202020204" pitchFamily="34" charset="0"/>
+              <a:buChar char="•"/>
+              <a:defRPr sz="1800" kern="1200">
+                <a:solidFill>
+                  <a:schemeClr val="tx1"/>
+                </a:solidFill>
+                <a:latin typeface="+mn-lt"/>
+                <a:ea typeface="+mn-ea"/>
+                <a:cs typeface="+mn-cs"/>
+              </a:defRPr>
+            </a:lvl6pPr>
+            <a:lvl7pPr marL="2971800" indent="-228600" algn="l" defTabSz="914400" rtl="0" eaLnBrk="1" latinLnBrk="0" hangingPunct="1">
+              <a:lnSpc>
+                <a:spcPct val="90000"/>
+              </a:lnSpc>
+              <a:spcBef>
+                <a:spcPts val="500"/>
+              </a:spcBef>
+              <a:buFont typeface="Arial" panose="020B0604020202020204" pitchFamily="34" charset="0"/>
+              <a:buChar char="•"/>
+              <a:defRPr sz="1800" kern="1200">
+                <a:solidFill>
+                  <a:schemeClr val="tx1"/>
+                </a:solidFill>
+                <a:latin typeface="+mn-lt"/>
+                <a:ea typeface="+mn-ea"/>
+                <a:cs typeface="+mn-cs"/>
+              </a:defRPr>
+            </a:lvl7pPr>
+            <a:lvl8pPr marL="3429000" indent="-228600" algn="l" defTabSz="914400" rtl="0" eaLnBrk="1" latinLnBrk="0" hangingPunct="1">
+              <a:lnSpc>
+                <a:spcPct val="90000"/>
+              </a:lnSpc>
+              <a:spcBef>
+                <a:spcPts val="500"/>
+              </a:spcBef>
+              <a:buFont typeface="Arial" panose="020B0604020202020204" pitchFamily="34" charset="0"/>
+              <a:buChar char="•"/>
+              <a:defRPr sz="1800" kern="1200">
+                <a:solidFill>
+                  <a:schemeClr val="tx1"/>
+                </a:solidFill>
+                <a:latin typeface="+mn-lt"/>
+                <a:ea typeface="+mn-ea"/>
+                <a:cs typeface="+mn-cs"/>
+              </a:defRPr>
+            </a:lvl8pPr>
+            <a:lvl9pPr marL="3886200" indent="-228600" algn="l" defTabSz="914400" rtl="0" eaLnBrk="1" latinLnBrk="0" hangingPunct="1">
+              <a:lnSpc>
+                <a:spcPct val="90000"/>
+              </a:lnSpc>
+              <a:spcBef>
+                <a:spcPts val="500"/>
+              </a:spcBef>
+              <a:buFont typeface="Arial" panose="020B0604020202020204" pitchFamily="34" charset="0"/>
+              <a:buChar char="•"/>
+              <a:defRPr sz="1800" kern="1200">
+                <a:solidFill>
+                  <a:schemeClr val="tx1"/>
+                </a:solidFill>
+                <a:latin typeface="+mn-lt"/>
+                <a:ea typeface="+mn-ea"/>
+                <a:cs typeface="+mn-cs"/>
+              </a:defRPr>
+            </a:lvl9pPr>
+          </a:lstStyle>
+          <a:p>
+            <a:r>
+              <a:rPr lang="en-US" dirty="0"/>
+              <a:t>For each property with pattern “</a:t>
+            </a:r>
+            <a:r>
+              <a:rPr lang="en-US" dirty="0" err="1"/>
+              <a:t>datacube</a:t>
+            </a:r>
+            <a:r>
+              <a:rPr lang="en-US" dirty="0"/>
+              <a:t>”, add an entry to the field catalog:</a:t>
+            </a:r>
+          </a:p>
+          <a:p>
+            <a:pPr marL="0" indent="0">
+              <a:buFont typeface="Arial" panose="020B0604020202020204" pitchFamily="34" charset="0"/>
+              <a:buNone/>
+            </a:pPr>
+            <a:endParaRPr lang="en-US" dirty="0"/>
+          </a:p>
+        </p:txBody>
+      </p:sp>
     </p:spTree>
     <p:extLst>
       <p:ext uri="{BB962C8B-B14F-4D97-AF65-F5344CB8AC3E}">
@@ -4217,10 +4468,155 @@
           </a:prstGeom>
         </p:spPr>
       </p:pic>
+      <p:pic>
+        <p:nvPicPr>
+          <p:cNvPr id="6" name="Picture 5">
+            <a:extLst>
+              <a:ext uri="{FF2B5EF4-FFF2-40B4-BE49-F238E27FC236}">
+                <a16:creationId xmlns:a16="http://schemas.microsoft.com/office/drawing/2014/main" id="{366C5169-7262-EA7F-3585-F047C965C2A6}"/>
+              </a:ext>
+            </a:extLst>
+          </p:cNvPr>
+          <p:cNvPicPr>
+            <a:picLocks noChangeAspect="1"/>
+          </p:cNvPicPr>
+          <p:nvPr/>
+        </p:nvPicPr>
+        <p:blipFill>
+          <a:blip r:embed="rId5"/>
+          <a:stretch>
+            <a:fillRect/>
+          </a:stretch>
+        </p:blipFill>
+        <p:spPr>
+          <a:xfrm>
+            <a:off x="6191997" y="1457764"/>
+            <a:ext cx="5430008" cy="4525006"/>
+          </a:xfrm>
+          <a:prstGeom prst="rect">
+            <a:avLst/>
+          </a:prstGeom>
+        </p:spPr>
+      </p:pic>
+      <p:pic>
+        <p:nvPicPr>
+          <p:cNvPr id="9" name="Picture 8">
+            <a:extLst>
+              <a:ext uri="{FF2B5EF4-FFF2-40B4-BE49-F238E27FC236}">
+                <a16:creationId xmlns:a16="http://schemas.microsoft.com/office/drawing/2014/main" id="{C9B9211E-10D1-52EC-AF1A-E1F8BA998CB3}"/>
+              </a:ext>
+            </a:extLst>
+          </p:cNvPr>
+          <p:cNvPicPr>
+            <a:picLocks noChangeAspect="1"/>
+          </p:cNvPicPr>
+          <p:nvPr/>
+        </p:nvPicPr>
+        <p:blipFill>
+          <a:blip r:embed="rId6"/>
+          <a:stretch>
+            <a:fillRect/>
+          </a:stretch>
+        </p:blipFill>
+        <p:spPr>
+          <a:xfrm>
+            <a:off x="742203" y="4111318"/>
+            <a:ext cx="5363323" cy="2200582"/>
+          </a:xfrm>
+          <a:prstGeom prst="rect">
+            <a:avLst/>
+          </a:prstGeom>
+        </p:spPr>
+      </p:pic>
     </p:spTree>
     <p:extLst>
       <p:ext uri="{BB962C8B-B14F-4D97-AF65-F5344CB8AC3E}">
         <p14:creationId xmlns:p14="http://schemas.microsoft.com/office/powerpoint/2010/main" val="2885429117"/>
+      </p:ext>
+    </p:extLst>
+  </p:cSld>
+  <p:clrMapOvr>
+    <a:masterClrMapping/>
+  </p:clrMapOvr>
+</p:sld>
+</file>
+
+<file path=ppt/slides/slide13.xml><?xml version="1.0" encoding="utf-8"?>
+<p:sld xmlns:a="http://schemas.openxmlformats.org/drawingml/2006/main" xmlns:r="http://schemas.openxmlformats.org/officeDocument/2006/relationships" xmlns:p="http://schemas.openxmlformats.org/presentationml/2006/main">
+  <p:cSld>
+    <p:spTree>
+      <p:nvGrpSpPr>
+        <p:cNvPr id="1" name=""/>
+        <p:cNvGrpSpPr/>
+        <p:nvPr/>
+      </p:nvGrpSpPr>
+      <p:grpSpPr>
+        <a:xfrm>
+          <a:off x="0" y="0"/>
+          <a:ext cx="0" cy="0"/>
+          <a:chOff x="0" y="0"/>
+          <a:chExt cx="0" cy="0"/>
+        </a:xfrm>
+      </p:grpSpPr>
+      <p:sp>
+        <p:nvSpPr>
+          <p:cNvPr id="2" name="Title 1">
+            <a:extLst>
+              <a:ext uri="{FF2B5EF4-FFF2-40B4-BE49-F238E27FC236}">
+                <a16:creationId xmlns:a16="http://schemas.microsoft.com/office/drawing/2014/main" id="{4290B844-515A-0520-79E4-4165F6E79CE3}"/>
+              </a:ext>
+            </a:extLst>
+          </p:cNvPr>
+          <p:cNvSpPr>
+            <a:spLocks noGrp="1"/>
+          </p:cNvSpPr>
+          <p:nvPr>
+            <p:ph type="title"/>
+          </p:nvPr>
+        </p:nvSpPr>
+        <p:spPr/>
+        <p:txBody>
+          <a:bodyPr>
+            <a:normAutofit/>
+          </a:bodyPr>
+          <a:lstStyle/>
+          <a:p>
+            <a:r>
+              <a:rPr lang="en-US" dirty="0"/>
+              <a:t>Join Measurement File with Field Catalog</a:t>
+            </a:r>
+          </a:p>
+        </p:txBody>
+      </p:sp>
+      <p:sp>
+        <p:nvSpPr>
+          <p:cNvPr id="3" name="Content Placeholder 2">
+            <a:extLst>
+              <a:ext uri="{FF2B5EF4-FFF2-40B4-BE49-F238E27FC236}">
+                <a16:creationId xmlns:a16="http://schemas.microsoft.com/office/drawing/2014/main" id="{E72B8013-5A96-19C3-594B-23DFD468CC01}"/>
+              </a:ext>
+            </a:extLst>
+          </p:cNvPr>
+          <p:cNvSpPr>
+            <a:spLocks noGrp="1"/>
+          </p:cNvSpPr>
+          <p:nvPr>
+            <p:ph idx="1"/>
+          </p:nvPr>
+        </p:nvSpPr>
+        <p:spPr/>
+        <p:txBody>
+          <a:bodyPr/>
+          <a:lstStyle/>
+          <a:p>
+            <a:endParaRPr lang="en-US"/>
+          </a:p>
+        </p:txBody>
+      </p:sp>
+    </p:spTree>
+    <p:extLst>
+      <p:ext uri="{BB962C8B-B14F-4D97-AF65-F5344CB8AC3E}">
+        <p14:creationId xmlns:p14="http://schemas.microsoft.com/office/powerpoint/2010/main" val="122710628"/>
       </p:ext>
     </p:extLst>
   </p:cSld>

</xml_diff>